<commit_message>
feat: updated docs with latest feature and implementations;
</commit_message>
<xml_diff>
--- a/docs/presentations/agent-azure-farsight-overview.pptx
+++ b/docs/presentations/agent-azure-farsight-overview.pptx
@@ -7912,7 +7912,7 @@
                 <a:ea typeface="Aptos" pitchFamily="34" charset="-122"/>
                 <a:cs typeface="Aptos" pitchFamily="34" charset="-120"/>
               </a:rPr>
-              <a:t>modules for Container Apps, Cosmos, Service Bus, Storage, Monitoring, Security, Networking, optional APIM</a:t>
+              <a:t>modules for Container Apps, Cosmos, Storage, Monitoring, Security, Networking, optional APIM</a:t>
             </a:r>
             <a:endParaRPr lang="en-US" sz="980" dirty="0"/>
           </a:p>
@@ -9319,7 +9319,7 @@
                 <a:ea typeface="Aptos" pitchFamily="34" charset="-122"/>
                 <a:cs typeface="Aptos" pitchFamily="34" charset="-120"/>
               </a:rPr>
-              <a:t>dead-lettered jobs</a:t>
+              <a:t>expired jobs</a:t>
             </a:r>
             <a:endParaRPr lang="en-US" sz="920" dirty="0"/>
           </a:p>
@@ -9904,7 +9904,7 @@
                 <a:ea typeface="Aptos" pitchFamily="34" charset="-122"/>
                 <a:cs typeface="Aptos" pitchFamily="34" charset="-120"/>
               </a:rPr>
-              <a:t>Alerts: heartbeats, stale leases, DLQ, API errors, RU throttling</a:t>
+              <a:t>Alerts: heartbeats, stale leases, API errors, RU throttling</a:t>
             </a:r>
             <a:endParaRPr lang="en-US" sz="980" dirty="0"/>
           </a:p>
@@ -10418,7 +10418,7 @@
                 <a:ea typeface="Aptos" pitchFamily="34" charset="-122"/>
                 <a:cs typeface="Aptos" pitchFamily="34" charset="-120"/>
               </a:rPr>
-              <a:t>API + Cosmos + Service Bus</a:t>
+              <a:t>API + Cosmos + Blob Storage</a:t>
             </a:r>
             <a:endParaRPr lang="en-US" sz="980" dirty="0"/>
           </a:p>
@@ -12432,7 +12432,7 @@
                 <a:ea typeface="Aptos" pitchFamily="34" charset="-122"/>
                 <a:cs typeface="Aptos" pitchFamily="34" charset="-120"/>
               </a:rPr>
-              <a:t>Cosmos containers and Service Bus queue</a:t>
+              <a:t>Cosmos containers and artifact storage</a:t>
             </a:r>
             <a:endParaRPr lang="en-US" sz="980" dirty="0"/>
           </a:p>
@@ -14792,7 +14792,7 @@
                 <a:ea typeface="Aptos" pitchFamily="34" charset="-122"/>
                 <a:cs typeface="Aptos" pitchFamily="34" charset="-120"/>
               </a:rPr>
-              <a:t>Custom HTTPS control API backed by Service Bus and Cosmos DB.</a:t>
+              <a:t>Custom HTTPS control API backed by Cosmos DB and Blob Storage.</a:t>
             </a:r>
             <a:endParaRPr lang="en-US" sz="980" dirty="0"/>
           </a:p>
@@ -18409,7 +18409,7 @@
                 <a:ea typeface="Aptos" pitchFamily="34" charset="-122"/>
                 <a:cs typeface="Aptos" pitchFamily="34" charset="-120"/>
               </a:rPr>
-              <a:t>Service Bus broker</a:t>
+              <a:t>Cosmos DB state</a:t>
             </a:r>
             <a:endParaRPr lang="en-US" sz="980" dirty="0"/>
           </a:p>
@@ -20348,7 +20348,7 @@
                 <a:ea typeface="Aptos" pitchFamily="34" charset="-122"/>
                 <a:cs typeface="Aptos" pitchFamily="34" charset="-120"/>
               </a:rPr>
-              <a:t>Broker</a:t>
+              <a:t>State</a:t>
             </a:r>
             <a:endParaRPr lang="en-US" sz="1320" dirty="0"/>
           </a:p>
@@ -20389,7 +20389,7 @@
                 <a:ea typeface="Aptos" pitchFamily="34" charset="-122"/>
                 <a:cs typeface="Aptos" pitchFamily="34" charset="-120"/>
               </a:rPr>
-              <a:t>Service Bus</a:t>
+              <a:t>Cosmos DB</a:t>
             </a:r>
             <a:endParaRPr lang="en-US" sz="840" dirty="0"/>
           </a:p>
@@ -20430,7 +20430,7 @@
                 <a:ea typeface="Aptos" pitchFamily="34" charset="-122"/>
                 <a:cs typeface="Aptos" pitchFamily="34" charset="-120"/>
               </a:rPr>
-              <a:t>Sessions by device</a:t>
+              <a:t>Jobs keyed by device</a:t>
             </a:r>
             <a:endParaRPr lang="en-US" sz="840" dirty="0"/>
           </a:p>
@@ -22205,7 +22205,7 @@
                 <a:ea typeface="Aptos" pitchFamily="34" charset="-122"/>
                 <a:cs typeface="Aptos" pitchFamily="34" charset="-120"/>
               </a:rPr>
-              <a:t>enqueues metadata</a:t>
+              <a:t>persists job state</a:t>
             </a:r>
             <a:endParaRPr lang="en-US" sz="820" dirty="0"/>
           </a:p>
@@ -22829,7 +22829,7 @@
                 <a:ea typeface="Aptos" pitchFamily="34" charset="-122"/>
                 <a:cs typeface="Aptos" pitchFamily="34" charset="-120"/>
               </a:rPr>
-              <a:t>Durable broker</a:t>
+              <a:t>Durable state</a:t>
             </a:r>
             <a:endParaRPr lang="en-US" sz="1320" dirty="0"/>
           </a:p>
@@ -22870,7 +22870,7 @@
                 <a:ea typeface="Aptos" pitchFamily="34" charset="-122"/>
                 <a:cs typeface="Aptos" pitchFamily="34" charset="-120"/>
               </a:rPr>
-              <a:t>Service Bus uses a session-enabled jobs queue keyed by deviceId.</a:t>
+              <a:t>Cosmos DB provides durable job state keyed by deviceId.</a:t>
             </a:r>
             <a:endParaRPr lang="en-US" sz="880" dirty="0"/>
           </a:p>

</xml_diff>